<commit_message>
GAVEL: the deck and the proposal answer the whole brief — limitations, scope, honest record
</commit_message>
<xml_diff>
--- a/submission/GAVEL-pitch.pptx
+++ b/submission/GAVEL-pitch.pptx
@@ -15,8 +15,9 @@
     <p:sldId id="264" r:id="rId10"/>
     <p:sldId id="265" r:id="rId11"/>
     <p:sldId id="266" r:id="rId12"/>
-    <p:sldId id="268" r:id="rId14"/>
-    <p:sldId id="269" r:id="rId15"/>
+    <p:sldId id="270" r:id="rId16"/>
+    <p:sldId id="271" r:id="rId17"/>
+    <p:sldId id="272" r:id="rId18"/>
   </p:sldIdLst>
   <p:sldSz cx="12192000" cy="6858000"/>
   <p:notesSz cx="6858000" cy="9144000"/>
@@ -823,7 +824,7 @@
                 <a:latin typeface="Courier New"/>
                 <a:ea typeface="Courier New"/>
               </a:rPr>
-              <a:t>09 / 12</a:t>
+              <a:t>09 / 13</a:t>
             </a:r>
           </a:p>
         </p:txBody>
@@ -1464,7 +1465,7 @@
                 <a:latin typeface="Courier New"/>
                 <a:ea typeface="Courier New"/>
               </a:rPr>
-              <a:t>10 / 12</a:t>
+              <a:t>10 / 13</a:t>
             </a:r>
           </a:p>
         </p:txBody>
@@ -1477,7 +1478,592 @@
 </p:sld>
 </file>
 
-<file path=ppt/slides/slide13.xml><?xml version="1.0" encoding="utf-8"?>
+<file path=ppt/slides/slide15.xml><?xml version="1.0" encoding="utf-8"?>
+<p:sld xmlns:a="http://schemas.openxmlformats.org/drawingml/2006/main" xmlns:r="http://schemas.openxmlformats.org/officeDocument/2006/relationships" xmlns:p="http://schemas.openxmlformats.org/presentationml/2006/main">
+  <p:cSld>
+    <p:bg>
+      <p:bgPr>
+        <a:solidFill>
+          <a:srgbClr val="ECE1C9"/>
+        </a:solidFill>
+        <a:effectLst/>
+      </p:bgPr>
+    </p:bg>
+    <p:spTree>
+      <p:nvGrpSpPr>
+        <p:cNvPr id="1" name=""/>
+        <p:cNvGrpSpPr/>
+        <p:nvPr/>
+      </p:nvGrpSpPr>
+      <p:grpSpPr>
+        <a:xfrm>
+          <a:off x="0" y="0"/>
+          <a:ext cx="0" cy="0"/>
+          <a:chOff x="0" y="0"/>
+          <a:chExt cx="0" cy="0"/>
+        </a:xfrm>
+      </p:grpSpPr>
+      <p:sp>
+        <p:nvSpPr>
+          <p:cNvPr id="3" name="Shape 3">
+            <a:extLst>
+              <a:ext uri="{FF2B5EF4-FFF2-40B4-BE49-F238E27FC236}">
+                <a16:creationId xmlns:a16="http://schemas.microsoft.com/office/drawing/2014/main" id="{F761DAA1-A429-4B12-BBBB-C0E4725FCDAE}"/>
+              </a:ext>
+            </a:extLst>
+          </p:cNvPr>
+          <p:cNvSpPr/>
+          <p:nvPr/>
+        </p:nvSpPr>
+        <p:spPr>
+          <a:xfrm>
+            <a:off x="666750" y="1809750"/>
+            <a:ext cx="5219700" cy="4095750"/>
+          </a:xfrm>
+          <a:prstGeom prst="roundRect">
+            <a:avLst/>
+          </a:prstGeom>
+          <a:solidFill>
+            <a:srgbClr val="FAF4E4"/>
+          </a:solidFill>
+          <a:ln w="12700">
+            <a:solidFill>
+              <a:srgbClr val="DDCDA9"/>
+            </a:solidFill>
+          </a:ln>
+        </p:spPr>
+        <p:txBody>
+          <a:bodyPr wrap="square" rtlCol="0"/>
+          <a:lstStyle/>
+          <a:p>
+            <a:r>
+              <a:rPr/>
+              <a:t/>
+            </a:r>
+          </a:p>
+        </p:txBody>
+      </p:sp>
+      <p:sp>
+        <p:nvSpPr>
+          <p:cNvPr id="4" name="Shape 4">
+            <a:extLst>
+              <a:ext uri="{FF2B5EF4-FFF2-40B4-BE49-F238E27FC236}">
+                <a16:creationId xmlns:a16="http://schemas.microsoft.com/office/drawing/2014/main" id="{8A703B76-DF7B-4553-8A4C-05A4D28F6C9B}"/>
+              </a:ext>
+            </a:extLst>
+          </p:cNvPr>
+          <p:cNvSpPr/>
+          <p:nvPr/>
+        </p:nvSpPr>
+        <p:spPr>
+          <a:xfrm>
+            <a:off x="6305550" y="1809750"/>
+            <a:ext cx="5219700" cy="4095750"/>
+          </a:xfrm>
+          <a:prstGeom prst="roundRect">
+            <a:avLst/>
+          </a:prstGeom>
+          <a:solidFill>
+            <a:srgbClr val="FAF4E4"/>
+          </a:solidFill>
+          <a:ln w="12700">
+            <a:solidFill>
+              <a:srgbClr val="DDCDA9"/>
+            </a:solidFill>
+          </a:ln>
+        </p:spPr>
+        <p:txBody>
+          <a:bodyPr wrap="square" rtlCol="0"/>
+          <a:lstStyle/>
+          <a:p>
+            <a:r>
+              <a:rPr/>
+              <a:t/>
+            </a:r>
+          </a:p>
+        </p:txBody>
+      </p:sp>
+      <p:sp>
+        <p:nvSpPr>
+          <p:cNvPr id="5" name="TextBox 5">
+            <a:extLst>
+              <a:ext uri="{FF2B5EF4-FFF2-40B4-BE49-F238E27FC236}">
+                <a16:creationId xmlns:a16="http://schemas.microsoft.com/office/drawing/2014/main" id="{519F29DD-B243-496A-995C-D61F208CB5FD}"/>
+              </a:ext>
+            </a:extLst>
+          </p:cNvPr>
+          <p:cNvSpPr txBox="1"/>
+          <p:nvPr/>
+        </p:nvSpPr>
+        <p:spPr>
+          <a:xfrm>
+            <a:off x="666750" y="495300"/>
+            <a:ext cx="4762500" cy="209550"/>
+          </a:xfrm>
+        </p:spPr>
+        <p:txBody>
+          <a:bodyPr wrap="square" rtlCol="0" lIns="0" tIns="0" rIns="0" bIns="0" anchor="t"/>
+          <a:lstStyle/>
+          <a:p>
+            <a:pPr algn="l"/>
+            <a:r>
+              <a:rPr sz="1300" b="1">
+                <a:solidFill>
+                  <a:srgbClr val="A8823A"/>
+                </a:solidFill>
+                <a:latin typeface="Courier New"/>
+                <a:ea typeface="Courier New"/>
+              </a:rPr>
+              <a:t>THE HONEST RECORD</a:t>
+            </a:r>
+          </a:p>
+        </p:txBody>
+      </p:sp>
+      <p:sp>
+        <p:nvSpPr>
+          <p:cNvPr id="6" name="TextBox 6">
+            <a:extLst>
+              <a:ext uri="{FF2B5EF4-FFF2-40B4-BE49-F238E27FC236}">
+                <a16:creationId xmlns:a16="http://schemas.microsoft.com/office/drawing/2014/main" id="{756C12C9-2057-40AC-9E93-71CF71506DB8}"/>
+              </a:ext>
+            </a:extLst>
+          </p:cNvPr>
+          <p:cNvSpPr txBox="1"/>
+          <p:nvPr/>
+        </p:nvSpPr>
+        <p:spPr>
+          <a:xfrm>
+            <a:off x="666750" y="762000"/>
+            <a:ext cx="10858500" cy="628650"/>
+          </a:xfrm>
+        </p:spPr>
+        <p:txBody>
+          <a:bodyPr wrap="square" rtlCol="0" lIns="0" tIns="0" rIns="0" bIns="0" anchor="t"/>
+          <a:lstStyle/>
+          <a:p>
+            <a:pPr algn="l"/>
+            <a:r>
+              <a:rPr sz="3600" b="1">
+                <a:solidFill>
+                  <a:srgbClr val="241C12"/>
+                </a:solidFill>
+                <a:latin typeface="Georgia"/>
+                <a:ea typeface="Georgia"/>
+              </a:rPr>
+              <a:t>What it cannot do — yet.</a:t>
+            </a:r>
+          </a:p>
+        </p:txBody>
+      </p:sp>
+      <p:sp>
+        <p:nvSpPr>
+          <p:cNvPr id="7" name="TextBox 7">
+            <a:extLst>
+              <a:ext uri="{FF2B5EF4-FFF2-40B4-BE49-F238E27FC236}">
+                <a16:creationId xmlns:a16="http://schemas.microsoft.com/office/drawing/2014/main" id="{317522F6-FD2B-4566-92F0-45D595012E7F}"/>
+              </a:ext>
+            </a:extLst>
+          </p:cNvPr>
+          <p:cNvSpPr txBox="1"/>
+          <p:nvPr/>
+        </p:nvSpPr>
+        <p:spPr>
+          <a:xfrm>
+            <a:off x="952500" y="2038350"/>
+            <a:ext cx="4648200" cy="228600"/>
+          </a:xfrm>
+        </p:spPr>
+        <p:txBody>
+          <a:bodyPr wrap="square" rtlCol="0" lIns="0" tIns="0" rIns="0" bIns="0" anchor="t"/>
+          <a:lstStyle/>
+          <a:p>
+            <a:pPr algn="l"/>
+            <a:r>
+              <a:rPr sz="1400" b="1">
+                <a:solidFill>
+                  <a:srgbClr val="7C1D17"/>
+                </a:solidFill>
+                <a:latin typeface="Courier New"/>
+                <a:ea typeface="Courier New"/>
+              </a:rPr>
+              <a:t>WHAT IT CANNOT DO</a:t>
+            </a:r>
+          </a:p>
+        </p:txBody>
+      </p:sp>
+      <p:sp>
+        <p:nvSpPr>
+          <p:cNvPr id="8" name="TextBox 8">
+            <a:extLst>
+              <a:ext uri="{FF2B5EF4-FFF2-40B4-BE49-F238E27FC236}">
+                <a16:creationId xmlns:a16="http://schemas.microsoft.com/office/drawing/2014/main" id="{56F5B9CB-0FCD-4C49-9654-6F31D8EDEB26}"/>
+              </a:ext>
+            </a:extLst>
+          </p:cNvPr>
+          <p:cNvSpPr txBox="1"/>
+          <p:nvPr/>
+        </p:nvSpPr>
+        <p:spPr>
+          <a:xfrm>
+            <a:off x="952500" y="2400300"/>
+            <a:ext cx="4648200" cy="3238500"/>
+          </a:xfrm>
+        </p:spPr>
+        <p:txBody>
+          <a:bodyPr wrap="square" rtlCol="0" lIns="0" tIns="0" rIns="0" bIns="0" anchor="t"/>
+          <a:lstStyle/>
+          <a:p>
+            <a:pPr algn="l">
+              <a:lnSpc>
+                <a:spcPct val="118000"/>
+              </a:lnSpc>
+              <a:spcAft>
+                <a:spcPts val="1200"/>
+              </a:spcAft>
+            </a:pPr>
+            <a:r>
+              <a:rPr sz="1250" b="1">
+                <a:solidFill>
+                  <a:srgbClr val="241C12"/>
+                </a:solidFill>
+                <a:latin typeface="Segoe UI"/>
+                <a:ea typeface="Segoe UI"/>
+              </a:rPr>
+              <a:t>Text and language</a:t>
+            </a:r>
+            <a:r>
+              <a:rPr sz="1250">
+                <a:solidFill>
+                  <a:srgbClr val="6A5A44"/>
+                </a:solidFill>
+                <a:latin typeface="Segoe UI"/>
+                <a:ea typeface="Segoe UI"/>
+              </a:rPr>
+              <a:t> — the classifier is trained on English-labelled SMS corpora; local slang beyond that leans on pattern rules.</a:t>
+            </a:r>
+          </a:p>
+          <a:p>
+            <a:pPr algn="l">
+              <a:lnSpc>
+                <a:spcPct val="118000"/>
+              </a:lnSpc>
+              <a:spcAft>
+                <a:spcPts val="1200"/>
+              </a:spcAft>
+            </a:pPr>
+            <a:r>
+              <a:rPr sz="1250" b="1">
+                <a:solidFill>
+                  <a:srgbClr val="241C12"/>
+                </a:solidFill>
+                <a:latin typeface="Segoe UI"/>
+                <a:ea typeface="Segoe UI"/>
+              </a:rPr>
+              <a:t>Anatomy, not reputation</a:t>
+            </a:r>
+            <a:r>
+              <a:rPr sz="1250">
+                <a:solidFill>
+                  <a:srgbClr val="6A5A44"/>
+                </a:solidFill>
+                <a:latin typeface="Segoe UI"/>
+                <a:ea typeface="Segoe UI"/>
+              </a:rPr>
+              <a:t> — links are judged offline by structure; domain age and live lookups are not consulted.</a:t>
+            </a:r>
+          </a:p>
+          <a:p>
+            <a:pPr algn="l">
+              <a:lnSpc>
+                <a:spcPct val="118000"/>
+              </a:lnSpc>
+              <a:spcAft>
+                <a:spcPts val="1200"/>
+              </a:spcAft>
+            </a:pPr>
+            <a:r>
+              <a:rPr sz="1250" b="1">
+                <a:solidFill>
+                  <a:srgbClr val="241C12"/>
+                </a:solidFill>
+                <a:latin typeface="Segoe UI"/>
+                <a:ea typeface="Segoe UI"/>
+              </a:rPr>
+              <a:t>A compiled voice when offline</a:t>
+            </a:r>
+            <a:r>
+              <a:rPr sz="1250">
+                <a:solidFill>
+                  <a:srgbClr val="6A5A44"/>
+                </a:solidFill>
+                <a:latin typeface="Segoe UI"/>
+                <a:ea typeface="Segoe UI"/>
+              </a:rPr>
+              <a:t> — without a model service the speeches are assembled, not drafted. The trial completes; the prose is plainer.</a:t>
+            </a:r>
+          </a:p>
+          <a:p>
+            <a:pPr algn="l">
+              <a:lnSpc>
+                <a:spcPct val="118000"/>
+              </a:lnSpc>
+              <a:spcAft>
+                <a:spcPts val="1200"/>
+              </a:spcAft>
+            </a:pPr>
+            <a:r>
+              <a:rPr sz="1250" b="1">
+                <a:solidFill>
+                  <a:srgbClr val="241C12"/>
+                </a:solidFill>
+                <a:latin typeface="Segoe UI"/>
+                <a:ea typeface="Segoe UI"/>
+              </a:rPr>
+              <a:t>Advice, never action</a:t>
+            </a:r>
+            <a:r>
+              <a:rPr sz="1250">
+                <a:solidFill>
+                  <a:srgbClr val="6A5A44"/>
+                </a:solidFill>
+                <a:latin typeface="Segoe UI"/>
+                <a:ea typeface="Segoe UI"/>
+              </a:rPr>
+              <a:t> — GAVEL blocks nothing and contacts no one. The decision stays where it belongs.</a:t>
+            </a:r>
+          </a:p>
+        </p:txBody>
+      </p:sp>
+      <p:sp>
+        <p:nvSpPr>
+          <p:cNvPr id="9" name="TextBox 9">
+            <a:extLst>
+              <a:ext uri="{FF2B5EF4-FFF2-40B4-BE49-F238E27FC236}">
+                <a16:creationId xmlns:a16="http://schemas.microsoft.com/office/drawing/2014/main" id="{94B92EF3-4CA4-46F6-8914-B90D3BD97C00}"/>
+              </a:ext>
+            </a:extLst>
+          </p:cNvPr>
+          <p:cNvSpPr txBox="1"/>
+          <p:nvPr/>
+        </p:nvSpPr>
+        <p:spPr>
+          <a:xfrm>
+            <a:off x="6591300" y="2038350"/>
+            <a:ext cx="4648200" cy="228600"/>
+          </a:xfrm>
+        </p:spPr>
+        <p:txBody>
+          <a:bodyPr wrap="square" rtlCol="0" lIns="0" tIns="0" rIns="0" bIns="0" anchor="t"/>
+          <a:lstStyle/>
+          <a:p>
+            <a:pPr algn="l"/>
+            <a:r>
+              <a:rPr sz="1400" b="1">
+                <a:solidFill>
+                  <a:srgbClr val="7C1D17"/>
+                </a:solidFill>
+                <a:latin typeface="Courier New"/>
+                <a:ea typeface="Courier New"/>
+              </a:rPr>
+              <a:t>WHAT COMES NEXT</a:t>
+            </a:r>
+          </a:p>
+        </p:txBody>
+      </p:sp>
+      <p:sp>
+        <p:nvSpPr>
+          <p:cNvPr id="10" name="TextBox 10">
+            <a:extLst>
+              <a:ext uri="{FF2B5EF4-FFF2-40B4-BE49-F238E27FC236}">
+                <a16:creationId xmlns:a16="http://schemas.microsoft.com/office/drawing/2014/main" id="{A6C0BB6B-2BCF-4054-AB60-C6BBD4564790}"/>
+              </a:ext>
+            </a:extLst>
+          </p:cNvPr>
+          <p:cNvSpPr txBox="1"/>
+          <p:nvPr/>
+        </p:nvSpPr>
+        <p:spPr>
+          <a:xfrm>
+            <a:off x="6591300" y="2400300"/>
+            <a:ext cx="4648200" cy="3238500"/>
+          </a:xfrm>
+        </p:spPr>
+        <p:txBody>
+          <a:bodyPr wrap="square" rtlCol="0" lIns="0" tIns="0" rIns="0" bIns="0" anchor="t"/>
+          <a:lstStyle/>
+          <a:p>
+            <a:pPr algn="l">
+              <a:lnSpc>
+                <a:spcPct val="118000"/>
+              </a:lnSpc>
+              <a:spcAft>
+                <a:spcPts val="1200"/>
+              </a:spcAft>
+            </a:pPr>
+            <a:r>
+              <a:rPr sz="1250" b="1">
+                <a:solidFill>
+                  <a:srgbClr val="241C12"/>
+                </a:solidFill>
+                <a:latin typeface="Segoe UI"/>
+                <a:ea typeface="Segoe UI"/>
+              </a:rPr>
+              <a:t>A public-record check</a:t>
+            </a:r>
+            <a:r>
+              <a:rPr sz="1250">
+                <a:solidFill>
+                  <a:srgbClr val="6A5A44"/>
+                </a:solidFill>
+                <a:latin typeface="Segoe UI"/>
+                <a:ea typeface="Segoe UI"/>
+              </a:rPr>
+              <a:t> — domain and phone reputation, consulted with consent, filed as one more exhibit.</a:t>
+            </a:r>
+          </a:p>
+          <a:p>
+            <a:pPr algn="l">
+              <a:lnSpc>
+                <a:spcPct val="118000"/>
+              </a:lnSpc>
+              <a:spcAft>
+                <a:spcPts val="1200"/>
+              </a:spcAft>
+            </a:pPr>
+            <a:r>
+              <a:rPr sz="1250" b="1">
+                <a:solidFill>
+                  <a:srgbClr val="241C12"/>
+                </a:solidFill>
+                <a:latin typeface="Segoe UI"/>
+                <a:ea typeface="Segoe UI"/>
+              </a:rPr>
+              <a:t>More local voices</a:t>
+            </a:r>
+            <a:r>
+              <a:rPr sz="1250">
+                <a:solidFill>
+                  <a:srgbClr val="6A5A44"/>
+                </a:solidFill>
+                <a:latin typeface="Segoe UI"/>
+                <a:ea typeface="Segoe UI"/>
+              </a:rPr>
+              <a:t> — Bahasa Malaysia and regional scam corpora, contributed with consent.</a:t>
+            </a:r>
+          </a:p>
+          <a:p>
+            <a:pPr algn="l">
+              <a:lnSpc>
+                <a:spcPct val="118000"/>
+              </a:lnSpc>
+              <a:spcAft>
+                <a:spcPts val="1200"/>
+              </a:spcAft>
+            </a:pPr>
+            <a:r>
+              <a:rPr sz="1250" b="1">
+                <a:solidFill>
+                  <a:srgbClr val="241C12"/>
+                </a:solidFill>
+                <a:latin typeface="Segoe UI"/>
+                <a:ea typeface="Segoe UI"/>
+              </a:rPr>
+              <a:t>A deeper school</a:t>
+            </a:r>
+            <a:r>
+              <a:rPr sz="1250">
+                <a:solidFill>
+                  <a:srgbClr val="6A5A44"/>
+                </a:solidFill>
+                <a:latin typeface="Segoe UI"/>
+                <a:ea typeface="Segoe UI"/>
+              </a:rPr>
+              <a:t> — case law that grows from real verdicts.</a:t>
+            </a:r>
+          </a:p>
+        </p:txBody>
+      </p:sp>
+      <p:sp>
+        <p:nvSpPr>
+          <p:cNvPr id="11" name="TextBox 11">
+            <a:extLst>
+              <a:ext uri="{FF2B5EF4-FFF2-40B4-BE49-F238E27FC236}">
+                <a16:creationId xmlns:a16="http://schemas.microsoft.com/office/drawing/2014/main" id="{6F994416-19C2-469D-8CBF-8EAEE46A2AB7}"/>
+              </a:ext>
+            </a:extLst>
+          </p:cNvPr>
+          <p:cNvSpPr txBox="1"/>
+          <p:nvPr/>
+        </p:nvSpPr>
+        <p:spPr>
+          <a:xfrm>
+            <a:off x="666750" y="6096000"/>
+            <a:ext cx="10858500" cy="247650"/>
+          </a:xfrm>
+        </p:spPr>
+        <p:txBody>
+          <a:bodyPr wrap="square" rtlCol="0" lIns="0" tIns="0" rIns="0" bIns="0" anchor="t"/>
+          <a:lstStyle/>
+          <a:p>
+            <a:pPr algn="l"/>
+            <a:r>
+              <a:rPr sz="1300">
+                <a:solidFill>
+                  <a:srgbClr val="6A5A44"/>
+                </a:solidFill>
+                <a:latin typeface="Courier New"/>
+                <a:ea typeface="Courier New"/>
+              </a:rPr>
+              <a:t>Limits are docketed, not hidden — uncertainty goes to a hung jury, never to a confident guess.</a:t>
+            </a:r>
+          </a:p>
+        </p:txBody>
+      </p:sp>
+      <p:sp>
+        <p:nvSpPr>
+          <p:cNvPr id="12" name="TextBox 12">
+            <a:extLst>
+              <a:ext uri="{FF2B5EF4-FFF2-40B4-BE49-F238E27FC236}">
+                <a16:creationId xmlns:a16="http://schemas.microsoft.com/office/drawing/2014/main" id="{16367940-5E7A-4808-BBC3-C8C7D9C8E092}"/>
+              </a:ext>
+            </a:extLst>
+          </p:cNvPr>
+          <p:cNvSpPr txBox="1"/>
+          <p:nvPr/>
+        </p:nvSpPr>
+        <p:spPr>
+          <a:xfrm>
+            <a:off x="10953750" y="6381750"/>
+            <a:ext cx="666750" cy="171450"/>
+          </a:xfrm>
+        </p:spPr>
+        <p:txBody>
+          <a:bodyPr wrap="square" rtlCol="0" lIns="0" tIns="0" rIns="0" bIns="0" anchor="t"/>
+          <a:lstStyle/>
+          <a:p>
+            <a:pPr algn="r"/>
+            <a:r>
+              <a:rPr sz="1100">
+                <a:solidFill>
+                  <a:srgbClr val="A08E6C"/>
+                </a:solidFill>
+                <a:latin typeface="Courier New"/>
+                <a:ea typeface="Courier New"/>
+              </a:rPr>
+              <a:t>12 / 13</a:t>
+            </a:r>
+          </a:p>
+        </p:txBody>
+      </p:sp>
+    </p:spTree>
+  </p:cSld>
+  <p:clrMapOvr>
+    <a:masterClrMapping/>
+  </p:clrMapOvr>
+</p:sld>
+</file>
+
+<file path=ppt/slides/slide16.xml><?xml version="1.0" encoding="utf-8"?>
 <p:sld xmlns:a="http://schemas.openxmlformats.org/drawingml/2006/main" xmlns:r="http://schemas.openxmlformats.org/officeDocument/2006/relationships" xmlns:p="http://schemas.openxmlformats.org/presentationml/2006/main">
   <p:cSld>
     <p:bg>
@@ -1507,7 +2093,7 @@
           <p:cNvPr id="3" name="Picture 3">
             <a:extLst>
               <a:ext uri="{FF2B5EF4-FFF2-40B4-BE49-F238E27FC236}">
-                <a16:creationId xmlns:a16="http://schemas.microsoft.com/office/drawing/2014/main" id="{389D877B-E4D9-44E0-B3E0-4B6E9EF549E0}"/>
+                <a16:creationId xmlns:a16="http://schemas.microsoft.com/office/drawing/2014/main" id="{6E1A41AD-975D-40F0-B81C-49D24BE0ED0A}"/>
               </a:ext>
             </a:extLst>
           </p:cNvPr>
@@ -1535,7 +2121,7 @@
           <p:cNvPr id="4" name="Picture 4">
             <a:extLst>
               <a:ext uri="{FF2B5EF4-FFF2-40B4-BE49-F238E27FC236}">
-                <a16:creationId xmlns:a16="http://schemas.microsoft.com/office/drawing/2014/main" id="{989AE00F-585C-486D-ACA6-08678AA08AE6}"/>
+                <a16:creationId xmlns:a16="http://schemas.microsoft.com/office/drawing/2014/main" id="{88216CDB-99BF-4679-9309-4703D12A55F6}"/>
               </a:ext>
             </a:extLst>
           </p:cNvPr>
@@ -1563,7 +2149,7 @@
           <p:cNvPr id="5" name="TextBox 5">
             <a:extLst>
               <a:ext uri="{FF2B5EF4-FFF2-40B4-BE49-F238E27FC236}">
-                <a16:creationId xmlns:a16="http://schemas.microsoft.com/office/drawing/2014/main" id="{352E5D89-E880-48E1-A437-E5F38BC214EB}"/>
+                <a16:creationId xmlns:a16="http://schemas.microsoft.com/office/drawing/2014/main" id="{B23A8F2E-9863-480B-8048-AE4FF5DEC9CB}"/>
               </a:ext>
             </a:extLst>
           </p:cNvPr>
@@ -1599,7 +2185,7 @@
           <p:cNvPr id="6" name="TextBox 6">
             <a:extLst>
               <a:ext uri="{FF2B5EF4-FFF2-40B4-BE49-F238E27FC236}">
-                <a16:creationId xmlns:a16="http://schemas.microsoft.com/office/drawing/2014/main" id="{99BA8D60-08F2-477E-99C9-32FED5EED702}"/>
+                <a16:creationId xmlns:a16="http://schemas.microsoft.com/office/drawing/2014/main" id="{309EA177-2224-4251-9ED8-A2FD058C4FD1}"/>
               </a:ext>
             </a:extLst>
           </p:cNvPr>
@@ -1635,7 +2221,7 @@
           <p:cNvPr id="7" name="TextBox 7">
             <a:extLst>
               <a:ext uri="{FF2B5EF4-FFF2-40B4-BE49-F238E27FC236}">
-                <a16:creationId xmlns:a16="http://schemas.microsoft.com/office/drawing/2014/main" id="{C8D7ED30-EF93-46BA-A89E-7C85FD383915}"/>
+                <a16:creationId xmlns:a16="http://schemas.microsoft.com/office/drawing/2014/main" id="{63A30F7E-3E78-4B9F-AD29-9697E39D3307}"/>
               </a:ext>
             </a:extLst>
           </p:cNvPr>
@@ -1671,7 +2257,7 @@
           <p:cNvPr id="8" name="TextBox 8">
             <a:extLst>
               <a:ext uri="{FF2B5EF4-FFF2-40B4-BE49-F238E27FC236}">
-                <a16:creationId xmlns:a16="http://schemas.microsoft.com/office/drawing/2014/main" id="{1EDB4CD1-B76E-43A0-B9E5-94AFA8957C73}"/>
+                <a16:creationId xmlns:a16="http://schemas.microsoft.com/office/drawing/2014/main" id="{0AD0A9D3-DE73-49C3-85F3-D42982CE2518}"/>
               </a:ext>
             </a:extLst>
           </p:cNvPr>
@@ -1784,7 +2370,7 @@
           <p:cNvPr id="9" name="TextBox 9">
             <a:extLst>
               <a:ext uri="{FF2B5EF4-FFF2-40B4-BE49-F238E27FC236}">
-                <a16:creationId xmlns:a16="http://schemas.microsoft.com/office/drawing/2014/main" id="{4C9B060E-19C1-494F-99A1-0F3C12129860}"/>
+                <a16:creationId xmlns:a16="http://schemas.microsoft.com/office/drawing/2014/main" id="{6BC17686-2517-4854-93F0-A0EC50634B45}"/>
               </a:ext>
             </a:extLst>
           </p:cNvPr>
@@ -1820,7 +2406,7 @@
           <p:cNvPr id="10" name="TextBox 10">
             <a:extLst>
               <a:ext uri="{FF2B5EF4-FFF2-40B4-BE49-F238E27FC236}">
-                <a16:creationId xmlns:a16="http://schemas.microsoft.com/office/drawing/2014/main" id="{DD585579-2938-47D0-B091-0368953AE22C}"/>
+                <a16:creationId xmlns:a16="http://schemas.microsoft.com/office/drawing/2014/main" id="{B00561A7-8966-48B1-BC72-EC80C14E03A3}"/>
               </a:ext>
             </a:extLst>
           </p:cNvPr>
@@ -1856,7 +2442,7 @@
           <p:cNvPr id="11" name="TextBox 11">
             <a:extLst>
               <a:ext uri="{FF2B5EF4-FFF2-40B4-BE49-F238E27FC236}">
-                <a16:creationId xmlns:a16="http://schemas.microsoft.com/office/drawing/2014/main" id="{F02F52BB-90C1-41E5-992E-2D0A33AE16F2}"/>
+                <a16:creationId xmlns:a16="http://schemas.microsoft.com/office/drawing/2014/main" id="{0E7590E8-7D70-4694-AFAD-FD09130ECBE8}"/>
               </a:ext>
             </a:extLst>
           </p:cNvPr>
@@ -1882,7 +2468,7 @@
                 <a:latin typeface="Courier New"/>
                 <a:ea typeface="Courier New"/>
               </a:rPr>
-              <a:t>11 / 12</a:t>
+              <a:t>13 / 13</a:t>
             </a:r>
           </a:p>
         </p:txBody>
@@ -1895,7 +2481,7 @@
 </p:sld>
 </file>
 
-<file path=ppt/slides/slide14.xml><?xml version="1.0" encoding="utf-8"?>
+<file path=ppt/slides/slide17.xml><?xml version="1.0" encoding="utf-8"?>
 <p:sld xmlns:a="http://schemas.openxmlformats.org/drawingml/2006/main" xmlns:r="http://schemas.openxmlformats.org/officeDocument/2006/relationships" xmlns:p="http://schemas.openxmlformats.org/presentationml/2006/main">
   <p:cSld>
     <p:bg>
@@ -1925,7 +2511,7 @@
           <p:cNvPr id="3" name="Shape 3">
             <a:extLst>
               <a:ext uri="{FF2B5EF4-FFF2-40B4-BE49-F238E27FC236}">
-                <a16:creationId xmlns:a16="http://schemas.microsoft.com/office/drawing/2014/main" id="{A1F460A7-4EF8-4F3F-B57C-31FAF40763E5}"/>
+                <a16:creationId xmlns:a16="http://schemas.microsoft.com/office/drawing/2014/main" id="{95F12689-C3C3-4D0E-B23C-9B618B410034}"/>
               </a:ext>
             </a:extLst>
           </p:cNvPr>
@@ -1960,7 +2546,7 @@
           <p:cNvPr id="4" name="Shape 4">
             <a:extLst>
               <a:ext uri="{FF2B5EF4-FFF2-40B4-BE49-F238E27FC236}">
-                <a16:creationId xmlns:a16="http://schemas.microsoft.com/office/drawing/2014/main" id="{7CF71E89-7B86-46C6-8B54-56D3BE79C9FF}"/>
+                <a16:creationId xmlns:a16="http://schemas.microsoft.com/office/drawing/2014/main" id="{91F1E35F-7673-44DF-9B3C-F5DED3EF8007}"/>
               </a:ext>
             </a:extLst>
           </p:cNvPr>
@@ -1995,7 +2581,7 @@
           <p:cNvPr id="5" name="Shape 5">
             <a:extLst>
               <a:ext uri="{FF2B5EF4-FFF2-40B4-BE49-F238E27FC236}">
-                <a16:creationId xmlns:a16="http://schemas.microsoft.com/office/drawing/2014/main" id="{E5F12791-2E17-4B38-A272-187A30724B25}"/>
+                <a16:creationId xmlns:a16="http://schemas.microsoft.com/office/drawing/2014/main" id="{2E312E68-8E7C-4FA4-B216-C8CC84EC69D2}"/>
               </a:ext>
             </a:extLst>
           </p:cNvPr>
@@ -2042,7 +2628,7 @@
           <p:cNvPr id="6" name="Shape 6">
             <a:extLst>
               <a:ext uri="{FF2B5EF4-FFF2-40B4-BE49-F238E27FC236}">
-                <a16:creationId xmlns:a16="http://schemas.microsoft.com/office/drawing/2014/main" id="{A2F5C655-CBDE-48BD-8F4A-5E720233FC54}"/>
+                <a16:creationId xmlns:a16="http://schemas.microsoft.com/office/drawing/2014/main" id="{EFE7B4FC-1F61-4BB9-8010-82D0C6C1A7D8}"/>
               </a:ext>
             </a:extLst>
           </p:cNvPr>
@@ -2089,7 +2675,7 @@
           <p:cNvPr id="7" name="Shape 7">
             <a:extLst>
               <a:ext uri="{FF2B5EF4-FFF2-40B4-BE49-F238E27FC236}">
-                <a16:creationId xmlns:a16="http://schemas.microsoft.com/office/drawing/2014/main" id="{9AAC5124-A154-483F-AD3F-131843E96973}"/>
+                <a16:creationId xmlns:a16="http://schemas.microsoft.com/office/drawing/2014/main" id="{F4551D5B-3003-4951-ADC2-933BBA1E107C}"/>
               </a:ext>
             </a:extLst>
           </p:cNvPr>
@@ -2136,7 +2722,7 @@
           <p:cNvPr id="8" name="TextBox 8">
             <a:extLst>
               <a:ext uri="{FF2B5EF4-FFF2-40B4-BE49-F238E27FC236}">
-                <a16:creationId xmlns:a16="http://schemas.microsoft.com/office/drawing/2014/main" id="{EEB01887-C990-4ADD-9538-70D422173FC1}"/>
+                <a16:creationId xmlns:a16="http://schemas.microsoft.com/office/drawing/2014/main" id="{5FE48891-6469-4F47-BA35-0AE74F498D2D}"/>
               </a:ext>
             </a:extLst>
           </p:cNvPr>
@@ -2172,7 +2758,7 @@
           <p:cNvPr id="9" name="TextBox 9">
             <a:extLst>
               <a:ext uri="{FF2B5EF4-FFF2-40B4-BE49-F238E27FC236}">
-                <a16:creationId xmlns:a16="http://schemas.microsoft.com/office/drawing/2014/main" id="{0E3C434D-72F5-44F1-ACAE-7C4F2BDF971B}"/>
+                <a16:creationId xmlns:a16="http://schemas.microsoft.com/office/drawing/2014/main" id="{3CE6D2D5-03B3-468B-9396-02C63E98CEAE}"/>
               </a:ext>
             </a:extLst>
           </p:cNvPr>
@@ -2208,7 +2794,7 @@
           <p:cNvPr id="10" name="TextBox 10">
             <a:extLst>
               <a:ext uri="{FF2B5EF4-FFF2-40B4-BE49-F238E27FC236}">
-                <a16:creationId xmlns:a16="http://schemas.microsoft.com/office/drawing/2014/main" id="{3E51334E-FA4D-4BA3-B177-47B06765635C}"/>
+                <a16:creationId xmlns:a16="http://schemas.microsoft.com/office/drawing/2014/main" id="{FB73AA3E-08DB-42F1-BA65-101E8814C9ED}"/>
               </a:ext>
             </a:extLst>
           </p:cNvPr>
@@ -2759,7 +3345,7 @@
                 <a:latin typeface="Courier New"/>
                 <a:ea typeface="Courier New"/>
               </a:rPr>
-              <a:t>02 / 12</a:t>
+              <a:t>02 / 13</a:t>
             </a:r>
           </a:p>
         </p:txBody>
@@ -3153,7 +3739,7 @@
                 <a:latin typeface="Courier New"/>
                 <a:ea typeface="Courier New"/>
               </a:rPr>
-              <a:t>03 / 12</a:t>
+              <a:t>03 / 13</a:t>
             </a:r>
           </a:p>
         </p:txBody>
@@ -4100,7 +4686,7 @@
                 <a:latin typeface="Courier New"/>
                 <a:ea typeface="Courier New"/>
               </a:rPr>
-              <a:t>04 / 12</a:t>
+              <a:t>04 / 13</a:t>
             </a:r>
           </a:p>
         </p:txBody>
@@ -4664,7 +5250,7 @@
                 <a:latin typeface="Courier New"/>
                 <a:ea typeface="Courier New"/>
               </a:rPr>
-              <a:t>05 / 12</a:t>
+              <a:t>05 / 13</a:t>
             </a:r>
           </a:p>
         </p:txBody>
@@ -4985,7 +5571,7 @@
                 <a:latin typeface="Courier New"/>
                 <a:ea typeface="Courier New"/>
               </a:rPr>
-              <a:t>06 / 12</a:t>
+              <a:t>06 / 13</a:t>
             </a:r>
           </a:p>
         </p:txBody>
@@ -5926,7 +6512,7 @@
                 <a:latin typeface="Courier New"/>
                 <a:ea typeface="Courier New"/>
               </a:rPr>
-              <a:t>07 / 12</a:t>
+              <a:t>07 / 13</a:t>
             </a:r>
           </a:p>
         </p:txBody>
@@ -6288,7 +6874,7 @@
                 <a:latin typeface="Courier New"/>
                 <a:ea typeface="Courier New"/>
               </a:rPr>
-              <a:t>08 / 12</a:t>
+              <a:t>08 / 13</a:t>
             </a:r>
           </a:p>
         </p:txBody>

</xml_diff>

<commit_message>
GAVEL: the exhibit gets its rounded corners back — seamless parchment card
</commit_message>
<xml_diff>
--- a/submission/GAVEL-pitch.pptx
+++ b/submission/GAVEL-pitch.pptx
@@ -10,7 +10,7 @@
     <p:sldId id="258" r:id="rId4"/>
     <p:sldId id="259" r:id="rId5"/>
     <p:sldId id="260" r:id="rId6"/>
-    <p:sldId id="261" r:id="rId7"/>
+    <p:sldId id="273" r:id="rId19"/>
     <p:sldId id="263" r:id="rId9"/>
     <p:sldId id="264" r:id="rId10"/>
     <p:sldId id="265" r:id="rId11"/>
@@ -2833,6 +2833,327 @@
 </p:sld>
 </file>
 
+<file path=ppt/slides/slide18.xml><?xml version="1.0" encoding="utf-8"?>
+<p:sld xmlns:a="http://schemas.openxmlformats.org/drawingml/2006/main" xmlns:r="http://schemas.openxmlformats.org/officeDocument/2006/relationships" xmlns:p="http://schemas.openxmlformats.org/presentationml/2006/main">
+  <p:cSld>
+    <p:bg>
+      <p:bgPr>
+        <a:solidFill>
+          <a:srgbClr val="2C2012"/>
+        </a:solidFill>
+        <a:effectLst/>
+      </p:bgPr>
+    </p:bg>
+    <p:spTree>
+      <p:nvGrpSpPr>
+        <p:cNvPr id="1" name=""/>
+        <p:cNvGrpSpPr/>
+        <p:nvPr/>
+      </p:nvGrpSpPr>
+      <p:grpSpPr>
+        <a:xfrm>
+          <a:off x="0" y="0"/>
+          <a:ext cx="0" cy="0"/>
+          <a:chOff x="0" y="0"/>
+          <a:chExt cx="0" cy="0"/>
+        </a:xfrm>
+      </p:grpSpPr>
+      <p:sp>
+        <p:nvSpPr>
+          <p:cNvPr id="3" name="Shape 3">
+            <a:extLst>
+              <a:ext uri="{FF2B5EF4-FFF2-40B4-BE49-F238E27FC236}">
+                <a16:creationId xmlns:a16="http://schemas.microsoft.com/office/drawing/2014/main" id="{109BF468-97E8-4567-9E4A-969AA3115176}"/>
+              </a:ext>
+            </a:extLst>
+          </p:cNvPr>
+          <p:cNvSpPr/>
+          <p:nvPr/>
+        </p:nvSpPr>
+        <p:spPr>
+          <a:xfrm>
+            <a:off x="1181100" y="2171700"/>
+            <a:ext cx="9829800" cy="2495550"/>
+          </a:xfrm>
+          <a:prstGeom prst="roundRect">
+            <a:avLst/>
+          </a:prstGeom>
+          <a:solidFill>
+            <a:srgbClr val="ECE1C9"/>
+          </a:solidFill>
+          <a:ln w="12700">
+            <a:solidFill>
+              <a:srgbClr val="A8823A"/>
+            </a:solidFill>
+          </a:ln>
+        </p:spPr>
+        <p:txBody>
+          <a:bodyPr wrap="square" rtlCol="0"/>
+          <a:lstStyle/>
+          <a:p>
+            <a:r>
+              <a:rPr/>
+              <a:t/>
+            </a:r>
+          </a:p>
+        </p:txBody>
+      </p:sp>
+      <p:pic>
+        <p:nvPicPr>
+          <p:cNvPr id="4" name="Picture 4">
+            <a:extLst>
+              <a:ext uri="{FF2B5EF4-FFF2-40B4-BE49-F238E27FC236}">
+                <a16:creationId xmlns:a16="http://schemas.microsoft.com/office/drawing/2014/main" id="{4BCD7F44-E846-41A4-A0BF-34EB627355B0}"/>
+              </a:ext>
+            </a:extLst>
+          </p:cNvPr>
+          <p:cNvPicPr/>
+          <p:nvPr/>
+        </p:nvPicPr>
+        <p:blipFill>
+          <a:blip r:embed="rId2"/>
+          <a:stretch>
+            <a:fillRect/>
+          </a:stretch>
+        </p:blipFill>
+        <p:spPr>
+          <a:xfrm>
+            <a:off x="1447800" y="2438400"/>
+            <a:ext cx="9296400" cy="1962150"/>
+          </a:xfrm>
+          <a:prstGeom prst="rect">
+            <a:avLst/>
+          </a:prstGeom>
+        </p:spPr>
+      </p:pic>
+      <p:sp>
+        <p:nvSpPr>
+          <p:cNvPr id="5" name="TextBox 5">
+            <a:extLst>
+              <a:ext uri="{FF2B5EF4-FFF2-40B4-BE49-F238E27FC236}">
+                <a16:creationId xmlns:a16="http://schemas.microsoft.com/office/drawing/2014/main" id="{A1253B8A-D205-4CC0-A9E1-0774A822B3C7}"/>
+              </a:ext>
+            </a:extLst>
+          </p:cNvPr>
+          <p:cNvSpPr txBox="1"/>
+          <p:nvPr/>
+        </p:nvSpPr>
+        <p:spPr>
+          <a:xfrm>
+            <a:off x="666750" y="495300"/>
+            <a:ext cx="5715000" cy="209550"/>
+          </a:xfrm>
+        </p:spPr>
+        <p:txBody>
+          <a:bodyPr wrap="square" rtlCol="0" lIns="0" tIns="0" rIns="0" bIns="0" anchor="t"/>
+          <a:lstStyle/>
+          <a:p>
+            <a:pPr algn="l"/>
+            <a:r>
+              <a:rPr sz="1300" b="1">
+                <a:solidFill>
+                  <a:srgbClr val="A8823A"/>
+                </a:solidFill>
+                <a:latin typeface="Courier New"/>
+                <a:ea typeface="Courier New"/>
+              </a:rPr>
+              <a:t>THE VERIFICATION GATE</a:t>
+            </a:r>
+          </a:p>
+        </p:txBody>
+      </p:sp>
+      <p:sp>
+        <p:nvSpPr>
+          <p:cNvPr id="6" name="TextBox 6">
+            <a:extLst>
+              <a:ext uri="{FF2B5EF4-FFF2-40B4-BE49-F238E27FC236}">
+                <a16:creationId xmlns:a16="http://schemas.microsoft.com/office/drawing/2014/main" id="{B4253829-FBC8-4560-866A-3B00C2E53803}"/>
+              </a:ext>
+            </a:extLst>
+          </p:cNvPr>
+          <p:cNvSpPr txBox="1"/>
+          <p:nvPr/>
+        </p:nvSpPr>
+        <p:spPr>
+          <a:xfrm>
+            <a:off x="666750" y="762000"/>
+            <a:ext cx="10477500" cy="628650"/>
+          </a:xfrm>
+        </p:spPr>
+        <p:txBody>
+          <a:bodyPr wrap="square" rtlCol="0" lIns="0" tIns="0" rIns="0" bIns="0" anchor="t"/>
+          <a:lstStyle/>
+          <a:p>
+            <a:pPr algn="l"/>
+            <a:r>
+              <a:rPr sz="3600" b="1">
+                <a:solidFill>
+                  <a:srgbClr val="F4EAD2"/>
+                </a:solidFill>
+                <a:latin typeface="Georgia"/>
+                <a:ea typeface="Georgia"/>
+              </a:rPr>
+              <a:t>Every word on screen is sourced.</a:t>
+            </a:r>
+          </a:p>
+        </p:txBody>
+      </p:sp>
+      <p:sp>
+        <p:nvSpPr>
+          <p:cNvPr id="7" name="TextBox 7">
+            <a:extLst>
+              <a:ext uri="{FF2B5EF4-FFF2-40B4-BE49-F238E27FC236}">
+                <a16:creationId xmlns:a16="http://schemas.microsoft.com/office/drawing/2014/main" id="{5AEB7F26-C888-4D01-B2F9-A157ECC9804B}"/>
+              </a:ext>
+            </a:extLst>
+          </p:cNvPr>
+          <p:cNvSpPr txBox="1"/>
+          <p:nvPr/>
+        </p:nvSpPr>
+        <p:spPr>
+          <a:xfrm>
+            <a:off x="666750" y="1771650"/>
+            <a:ext cx="10858500" cy="285750"/>
+          </a:xfrm>
+        </p:spPr>
+        <p:txBody>
+          <a:bodyPr wrap="square" rtlCol="0" lIns="0" tIns="0" rIns="0" bIns="0" anchor="t"/>
+          <a:lstStyle/>
+          <a:p>
+            <a:pPr algn="l"/>
+            <a:r>
+              <a:rPr sz="1500">
+                <a:solidFill>
+                  <a:srgbClr val="E6D7B2"/>
+                </a:solidFill>
+                <a:latin typeface="Segoe UI"/>
+                <a:ea typeface="Segoe UI"/>
+              </a:rPr>
+              <a:t>Every quoted word in a drafted speech must exist character-for-character in the court record.</a:t>
+            </a:r>
+          </a:p>
+        </p:txBody>
+      </p:sp>
+      <p:sp>
+        <p:nvSpPr>
+          <p:cNvPr id="8" name="TextBox 8">
+            <a:extLst>
+              <a:ext uri="{FF2B5EF4-FFF2-40B4-BE49-F238E27FC236}">
+                <a16:creationId xmlns:a16="http://schemas.microsoft.com/office/drawing/2014/main" id="{943BD412-1105-4AE6-8463-2509BBBB5AB9}"/>
+              </a:ext>
+            </a:extLst>
+          </p:cNvPr>
+          <p:cNvSpPr txBox="1"/>
+          <p:nvPr/>
+        </p:nvSpPr>
+        <p:spPr>
+          <a:xfrm>
+            <a:off x="1333500" y="4819650"/>
+            <a:ext cx="9525000" cy="190500"/>
+          </a:xfrm>
+        </p:spPr>
+        <p:txBody>
+          <a:bodyPr wrap="square" rtlCol="0" lIns="0" tIns="0" rIns="0" bIns="0" anchor="t"/>
+          <a:lstStyle/>
+          <a:p>
+            <a:pPr algn="ctr"/>
+            <a:r>
+              <a:rPr sz="1200">
+                <a:solidFill>
+                  <a:srgbClr val="A08E6C"/>
+                </a:solidFill>
+                <a:latin typeface="Courier New"/>
+                <a:ea typeface="Courier New"/>
+              </a:rPr>
+              <a:t>Exhibit A — quoted back onto the message itself, character for character.</a:t>
+            </a:r>
+          </a:p>
+        </p:txBody>
+      </p:sp>
+      <p:sp>
+        <p:nvSpPr>
+          <p:cNvPr id="9" name="TextBox 9">
+            <a:extLst>
+              <a:ext uri="{FF2B5EF4-FFF2-40B4-BE49-F238E27FC236}">
+                <a16:creationId xmlns:a16="http://schemas.microsoft.com/office/drawing/2014/main" id="{56A1FC39-2447-48A9-8AB7-782650CFC55E}"/>
+              </a:ext>
+            </a:extLst>
+          </p:cNvPr>
+          <p:cNvSpPr txBox="1"/>
+          <p:nvPr/>
+        </p:nvSpPr>
+        <p:spPr>
+          <a:xfrm>
+            <a:off x="666750" y="5200650"/>
+            <a:ext cx="10858500" cy="914400"/>
+          </a:xfrm>
+        </p:spPr>
+        <p:txBody>
+          <a:bodyPr wrap="square" rtlCol="0" lIns="0" tIns="0" rIns="0" bIns="0" anchor="t"/>
+          <a:lstStyle/>
+          <a:p>
+            <a:pPr algn="l">
+              <a:lnSpc>
+                <a:spcPct val="120000"/>
+              </a:lnSpc>
+            </a:pPr>
+            <a:r>
+              <a:rPr sz="1350">
+                <a:solidFill>
+                  <a:srgbClr val="E6D7B2"/>
+                </a:solidFill>
+                <a:latin typeface="Segoe UI"/>
+                <a:ea typeface="Segoe UI"/>
+              </a:rPr>
+              <a:t>A draft that invents evidence is discarded — fabricated quotes reach the screen zero times, by construction. No model? Offline, rate-limited, or failing the gate, the scripted bench compiles the officers' arguments deterministically from the exhibits — the courtroom completes every trial.</a:t>
+            </a:r>
+          </a:p>
+        </p:txBody>
+      </p:sp>
+      <p:sp>
+        <p:nvSpPr>
+          <p:cNvPr id="10" name="TextBox 10">
+            <a:extLst>
+              <a:ext uri="{FF2B5EF4-FFF2-40B4-BE49-F238E27FC236}">
+                <a16:creationId xmlns:a16="http://schemas.microsoft.com/office/drawing/2014/main" id="{0ABBD78F-A755-42DE-9265-EBC71605EBA4}"/>
+              </a:ext>
+            </a:extLst>
+          </p:cNvPr>
+          <p:cNvSpPr txBox="1"/>
+          <p:nvPr/>
+        </p:nvSpPr>
+        <p:spPr>
+          <a:xfrm>
+            <a:off x="10953750" y="6381750"/>
+            <a:ext cx="666750" cy="171450"/>
+          </a:xfrm>
+        </p:spPr>
+        <p:txBody>
+          <a:bodyPr wrap="square" rtlCol="0" lIns="0" tIns="0" rIns="0" bIns="0" anchor="t"/>
+          <a:lstStyle/>
+          <a:p>
+            <a:pPr algn="r"/>
+            <a:r>
+              <a:rPr sz="1100">
+                <a:solidFill>
+                  <a:srgbClr val="A08E6C"/>
+                </a:solidFill>
+                <a:latin typeface="Courier New"/>
+                <a:ea typeface="Courier New"/>
+              </a:rPr>
+              <a:t>06 / 13</a:t>
+            </a:r>
+          </a:p>
+        </p:txBody>
+      </p:sp>
+    </p:spTree>
+  </p:cSld>
+  <p:clrMapOvr>
+    <a:masterClrMapping/>
+  </p:clrMapOvr>
+</p:sld>
+</file>
+
 <file path=ppt/slides/slide2.xml><?xml version="1.0" encoding="utf-8"?>
 <p:sld xmlns:a="http://schemas.openxmlformats.org/drawingml/2006/main" xmlns:r="http://schemas.openxmlformats.org/officeDocument/2006/relationships" xmlns:p="http://schemas.openxmlformats.org/presentationml/2006/main">
   <p:cSld>
@@ -5251,327 +5572,6 @@
                 <a:ea typeface="Courier New"/>
               </a:rPr>
               <a:t>05 / 13</a:t>
-            </a:r>
-          </a:p>
-        </p:txBody>
-      </p:sp>
-    </p:spTree>
-  </p:cSld>
-  <p:clrMapOvr>
-    <a:masterClrMapping/>
-  </p:clrMapOvr>
-</p:sld>
-</file>
-
-<file path=ppt/slides/slide6.xml><?xml version="1.0" encoding="utf-8"?>
-<p:sld xmlns:a="http://schemas.openxmlformats.org/drawingml/2006/main" xmlns:r="http://schemas.openxmlformats.org/officeDocument/2006/relationships" xmlns:p="http://schemas.openxmlformats.org/presentationml/2006/main">
-  <p:cSld>
-    <p:bg>
-      <p:bgPr>
-        <a:solidFill>
-          <a:srgbClr val="2C2012"/>
-        </a:solidFill>
-        <a:effectLst/>
-      </p:bgPr>
-    </p:bg>
-    <p:spTree>
-      <p:nvGrpSpPr>
-        <p:cNvPr id="1" name=""/>
-        <p:cNvGrpSpPr/>
-        <p:nvPr/>
-      </p:nvGrpSpPr>
-      <p:grpSpPr>
-        <a:xfrm>
-          <a:off x="0" y="0"/>
-          <a:ext cx="0" cy="0"/>
-          <a:chOff x="0" y="0"/>
-          <a:chExt cx="0" cy="0"/>
-        </a:xfrm>
-      </p:grpSpPr>
-      <p:sp>
-        <p:nvSpPr>
-          <p:cNvPr id="3" name="Shape 3">
-            <a:extLst>
-              <a:ext uri="{FF2B5EF4-FFF2-40B4-BE49-F238E27FC236}">
-                <a16:creationId xmlns:a16="http://schemas.microsoft.com/office/drawing/2014/main" id="{DC015F5E-29B2-48EC-AE29-069D0A7DCC3D}"/>
-              </a:ext>
-            </a:extLst>
-          </p:cNvPr>
-          <p:cNvSpPr/>
-          <p:nvPr/>
-        </p:nvSpPr>
-        <p:spPr>
-          <a:xfrm>
-            <a:off x="1257300" y="2305050"/>
-            <a:ext cx="9677400" cy="2162175"/>
-          </a:xfrm>
-          <a:prstGeom prst="roundRect">
-            <a:avLst/>
-          </a:prstGeom>
-          <a:solidFill>
-            <a:srgbClr val="F6EFDC"/>
-          </a:solidFill>
-          <a:ln w="12700">
-            <a:solidFill>
-              <a:srgbClr val="DDCDA9"/>
-            </a:solidFill>
-          </a:ln>
-        </p:spPr>
-        <p:txBody>
-          <a:bodyPr wrap="square" rtlCol="0"/>
-          <a:lstStyle/>
-          <a:p>
-            <a:r>
-              <a:rPr/>
-              <a:t/>
-            </a:r>
-          </a:p>
-        </p:txBody>
-      </p:sp>
-      <p:pic>
-        <p:nvPicPr>
-          <p:cNvPr id="4" name="Picture 4">
-            <a:extLst>
-              <a:ext uri="{FF2B5EF4-FFF2-40B4-BE49-F238E27FC236}">
-                <a16:creationId xmlns:a16="http://schemas.microsoft.com/office/drawing/2014/main" id="{34E1DE55-523A-47FC-9F19-68CBF2F7C7B7}"/>
-              </a:ext>
-            </a:extLst>
-          </p:cNvPr>
-          <p:cNvPicPr/>
-          <p:nvPr/>
-        </p:nvPicPr>
-        <p:blipFill>
-          <a:blip r:embed="rId2"/>
-          <a:stretch>
-            <a:fillRect/>
-          </a:stretch>
-        </p:blipFill>
-        <p:spPr>
-          <a:xfrm>
-            <a:off x="1333500" y="2381250"/>
-            <a:ext cx="9525000" cy="2009775"/>
-          </a:xfrm>
-          <a:prstGeom prst="rect">
-            <a:avLst/>
-          </a:prstGeom>
-        </p:spPr>
-      </p:pic>
-      <p:sp>
-        <p:nvSpPr>
-          <p:cNvPr id="5" name="TextBox 5">
-            <a:extLst>
-              <a:ext uri="{FF2B5EF4-FFF2-40B4-BE49-F238E27FC236}">
-                <a16:creationId xmlns:a16="http://schemas.microsoft.com/office/drawing/2014/main" id="{E569188D-49EF-435C-96E5-2828ECAAAF5D}"/>
-              </a:ext>
-            </a:extLst>
-          </p:cNvPr>
-          <p:cNvSpPr txBox="1"/>
-          <p:nvPr/>
-        </p:nvSpPr>
-        <p:spPr>
-          <a:xfrm>
-            <a:off x="666750" y="495300"/>
-            <a:ext cx="5715000" cy="209550"/>
-          </a:xfrm>
-        </p:spPr>
-        <p:txBody>
-          <a:bodyPr wrap="square" rtlCol="0" lIns="0" tIns="0" rIns="0" bIns="0" anchor="t"/>
-          <a:lstStyle/>
-          <a:p>
-            <a:pPr algn="l"/>
-            <a:r>
-              <a:rPr sz="1300" b="1">
-                <a:solidFill>
-                  <a:srgbClr val="A8823A"/>
-                </a:solidFill>
-                <a:latin typeface="Courier New"/>
-                <a:ea typeface="Courier New"/>
-              </a:rPr>
-              <a:t>THE VERIFICATION GATE</a:t>
-            </a:r>
-          </a:p>
-        </p:txBody>
-      </p:sp>
-      <p:sp>
-        <p:nvSpPr>
-          <p:cNvPr id="6" name="TextBox 6">
-            <a:extLst>
-              <a:ext uri="{FF2B5EF4-FFF2-40B4-BE49-F238E27FC236}">
-                <a16:creationId xmlns:a16="http://schemas.microsoft.com/office/drawing/2014/main" id="{782602F0-1F55-49B6-BDD2-26939DB646C3}"/>
-              </a:ext>
-            </a:extLst>
-          </p:cNvPr>
-          <p:cNvSpPr txBox="1"/>
-          <p:nvPr/>
-        </p:nvSpPr>
-        <p:spPr>
-          <a:xfrm>
-            <a:off x="666750" y="762000"/>
-            <a:ext cx="10477500" cy="628650"/>
-          </a:xfrm>
-        </p:spPr>
-        <p:txBody>
-          <a:bodyPr wrap="square" rtlCol="0" lIns="0" tIns="0" rIns="0" bIns="0" anchor="t"/>
-          <a:lstStyle/>
-          <a:p>
-            <a:pPr algn="l"/>
-            <a:r>
-              <a:rPr sz="3600" b="1">
-                <a:solidFill>
-                  <a:srgbClr val="F4EAD2"/>
-                </a:solidFill>
-                <a:latin typeface="Georgia"/>
-                <a:ea typeface="Georgia"/>
-              </a:rPr>
-              <a:t>Every word on screen is sourced.</a:t>
-            </a:r>
-          </a:p>
-        </p:txBody>
-      </p:sp>
-      <p:sp>
-        <p:nvSpPr>
-          <p:cNvPr id="7" name="TextBox 7">
-            <a:extLst>
-              <a:ext uri="{FF2B5EF4-FFF2-40B4-BE49-F238E27FC236}">
-                <a16:creationId xmlns:a16="http://schemas.microsoft.com/office/drawing/2014/main" id="{D1E027B1-08C0-4B3D-8584-879693B94E05}"/>
-              </a:ext>
-            </a:extLst>
-          </p:cNvPr>
-          <p:cNvSpPr txBox="1"/>
-          <p:nvPr/>
-        </p:nvSpPr>
-        <p:spPr>
-          <a:xfrm>
-            <a:off x="666750" y="1809750"/>
-            <a:ext cx="10858500" cy="285750"/>
-          </a:xfrm>
-        </p:spPr>
-        <p:txBody>
-          <a:bodyPr wrap="square" rtlCol="0" lIns="0" tIns="0" rIns="0" bIns="0" anchor="t"/>
-          <a:lstStyle/>
-          <a:p>
-            <a:pPr algn="l"/>
-            <a:r>
-              <a:rPr sz="1500">
-                <a:solidFill>
-                  <a:srgbClr val="E6D7B2"/>
-                </a:solidFill>
-                <a:latin typeface="Segoe UI"/>
-                <a:ea typeface="Segoe UI"/>
-              </a:rPr>
-              <a:t>Every quoted word in a drafted speech must exist character-for-character in the court record.</a:t>
-            </a:r>
-          </a:p>
-        </p:txBody>
-      </p:sp>
-      <p:sp>
-        <p:nvSpPr>
-          <p:cNvPr id="8" name="TextBox 8">
-            <a:extLst>
-              <a:ext uri="{FF2B5EF4-FFF2-40B4-BE49-F238E27FC236}">
-                <a16:creationId xmlns:a16="http://schemas.microsoft.com/office/drawing/2014/main" id="{6C8B298F-7F20-4B2C-86F3-4094554436A6}"/>
-              </a:ext>
-            </a:extLst>
-          </p:cNvPr>
-          <p:cNvSpPr txBox="1"/>
-          <p:nvPr/>
-        </p:nvSpPr>
-        <p:spPr>
-          <a:xfrm>
-            <a:off x="1333500" y="4610100"/>
-            <a:ext cx="9525000" cy="190500"/>
-          </a:xfrm>
-        </p:spPr>
-        <p:txBody>
-          <a:bodyPr wrap="square" rtlCol="0" lIns="0" tIns="0" rIns="0" bIns="0" anchor="t"/>
-          <a:lstStyle/>
-          <a:p>
-            <a:pPr algn="ctr"/>
-            <a:r>
-              <a:rPr sz="1200">
-                <a:solidFill>
-                  <a:srgbClr val="A08E6C"/>
-                </a:solidFill>
-                <a:latin typeface="Courier New"/>
-                <a:ea typeface="Courier New"/>
-              </a:rPr>
-              <a:t>Exhibit A — quoted back onto the message itself, character for character.</a:t>
-            </a:r>
-          </a:p>
-        </p:txBody>
-      </p:sp>
-      <p:sp>
-        <p:nvSpPr>
-          <p:cNvPr id="9" name="TextBox 9">
-            <a:extLst>
-              <a:ext uri="{FF2B5EF4-FFF2-40B4-BE49-F238E27FC236}">
-                <a16:creationId xmlns:a16="http://schemas.microsoft.com/office/drawing/2014/main" id="{002C4379-2FA2-4493-9CF1-CCBCF1BED4FB}"/>
-              </a:ext>
-            </a:extLst>
-          </p:cNvPr>
-          <p:cNvSpPr txBox="1"/>
-          <p:nvPr/>
-        </p:nvSpPr>
-        <p:spPr>
-          <a:xfrm>
-            <a:off x="666750" y="5143500"/>
-            <a:ext cx="10858500" cy="914400"/>
-          </a:xfrm>
-        </p:spPr>
-        <p:txBody>
-          <a:bodyPr wrap="square" rtlCol="0" lIns="0" tIns="0" rIns="0" bIns="0" anchor="t"/>
-          <a:lstStyle/>
-          <a:p>
-            <a:pPr algn="l">
-              <a:lnSpc>
-                <a:spcPct val="120000"/>
-              </a:lnSpc>
-            </a:pPr>
-            <a:r>
-              <a:rPr sz="1350">
-                <a:solidFill>
-                  <a:srgbClr val="E6D7B2"/>
-                </a:solidFill>
-                <a:latin typeface="Segoe UI"/>
-                <a:ea typeface="Segoe UI"/>
-              </a:rPr>
-              <a:t>A draft that invents evidence is discarded — fabricated quotes reach the screen zero times, by construction. No model? Offline, rate-limited, or failing the gate, the scripted bench compiles the officers' arguments deterministically from the exhibits — the courtroom completes every trial.</a:t>
-            </a:r>
-          </a:p>
-        </p:txBody>
-      </p:sp>
-      <p:sp>
-        <p:nvSpPr>
-          <p:cNvPr id="10" name="TextBox 10">
-            <a:extLst>
-              <a:ext uri="{FF2B5EF4-FFF2-40B4-BE49-F238E27FC236}">
-                <a16:creationId xmlns:a16="http://schemas.microsoft.com/office/drawing/2014/main" id="{EA025497-D3B9-44CC-AE4B-0E69C0E4AEDF}"/>
-              </a:ext>
-            </a:extLst>
-          </p:cNvPr>
-          <p:cNvSpPr txBox="1"/>
-          <p:nvPr/>
-        </p:nvSpPr>
-        <p:spPr>
-          <a:xfrm>
-            <a:off x="10953750" y="6381750"/>
-            <a:ext cx="666750" cy="171450"/>
-          </a:xfrm>
-        </p:spPr>
-        <p:txBody>
-          <a:bodyPr wrap="square" rtlCol="0" lIns="0" tIns="0" rIns="0" bIns="0" anchor="t"/>
-          <a:lstStyle/>
-          <a:p>
-            <a:pPr algn="r"/>
-            <a:r>
-              <a:rPr sz="1100">
-                <a:solidFill>
-                  <a:srgbClr val="A08E6C"/>
-                </a:solidFill>
-                <a:latin typeface="Courier New"/>
-                <a:ea typeface="Courier New"/>
-              </a:rPr>
-              <a:t>06 / 13</a:t>
             </a:r>
           </a:p>
         </p:txBody>

</xml_diff>

<commit_message>
GAVEL: the page numbers count straight — 11 and 12 land where they should
</commit_message>
<xml_diff>
--- a/submission/GAVEL-pitch.pptx
+++ b/submission/GAVEL-pitch.pptx
@@ -2050,7 +2050,7 @@
                 <a:latin typeface="Courier New"/>
                 <a:ea typeface="Courier New"/>
               </a:rPr>
-              <a:t>12 / 13</a:t>
+              <a:t>11 / 13</a:t>
             </a:r>
           </a:p>
         </p:txBody>
@@ -2468,7 +2468,7 @@
                 <a:latin typeface="Courier New"/>
                 <a:ea typeface="Courier New"/>
               </a:rPr>
-              <a:t>13 / 13</a:t>
+              <a:t>12 / 13</a:t>
             </a:r>
           </a:p>
         </p:txBody>

</xml_diff>